<commit_message>
Add verification loop and fix PPTX/XLSX compatibility issues
Fixes:
- PPTX: add theme1.xml with color/font/format schemes — Keynote now opens files
- PPTX: slideMaster references theme via rId2
- XLSX: add cellStyles section to styles.xml — suppresses openpyxl warning

New:
- benchmarks/verify_generated.py: 3-level verification (structure, library, roundtrip)
- design_docs/planned/v0_6_0/verification_loop.md: verification strategy doc
- Regenerated all demo files with fixes

Remaining known issue: ODF mimetype entry is compressed (AILANG stdlib
limitation — createArchive has no store/no-compress flag). Files still
open in LibreOffice but may not be detected by MIME-type sniffers.

Co-Authored-By: Claude Opus 4.6 (1M context) <noreply@anthropic.com>
</commit_message>
<xml_diff>
--- a/data/examples/converted_sample.pptx
+++ b/data/examples/converted_sample.pptx
@@ -485,4 +485,113 @@
     </p:spTree>
   </p:cSld>
 </p:sld>
+</file>
+
+<file path=ppt/theme/theme1.xml><?xml version="1.0" encoding="utf-8"?>
+<a:theme xmlns:a="http://schemas.openxmlformats.org/drawingml/2006/main" name="DocParse">
+  <a:themeElements>
+    <a:clrScheme name="DocParse">
+      <a:dk1>
+        <a:srgbClr val="000000"/>
+      </a:dk1>
+      <a:lt1>
+        <a:srgbClr val="FFFFFF"/>
+      </a:lt1>
+      <a:dk2>
+        <a:srgbClr val="1F497D"/>
+      </a:dk2>
+      <a:lt2>
+        <a:srgbClr val="EEECE1"/>
+      </a:lt2>
+      <a:accent1>
+        <a:srgbClr val="4F81BD"/>
+      </a:accent1>
+      <a:accent2>
+        <a:srgbClr val="C0504D"/>
+      </a:accent2>
+      <a:accent3>
+        <a:srgbClr val="9BBB59"/>
+      </a:accent3>
+      <a:accent4>
+        <a:srgbClr val="8064A2"/>
+      </a:accent4>
+      <a:accent5>
+        <a:srgbClr val="4BACC6"/>
+      </a:accent5>
+      <a:accent6>
+        <a:srgbClr val="F79646"/>
+      </a:accent6>
+      <a:hlink>
+        <a:srgbClr val="0000FF"/>
+      </a:hlink>
+      <a:folHlink>
+        <a:srgbClr val="800080"/>
+      </a:folHlink>
+    </a:clrScheme>
+    <a:fontScheme name="DocParse">
+      <a:majorFont>
+        <a:latin typeface="Calibri"/>
+        <a:ea typeface=""/>
+        <a:cs typeface=""/>
+      </a:majorFont>
+      <a:minorFont>
+        <a:latin typeface="Calibri"/>
+        <a:ea typeface=""/>
+        <a:cs typeface=""/>
+      </a:minorFont>
+    </a:fontScheme>
+    <a:fmtScheme name="DocParse">
+      <a:fillStyleLst>
+        <a:solidFill>
+          <a:schemeClr val="phClr"/>
+        </a:solidFill>
+        <a:solidFill>
+          <a:schemeClr val="phClr"/>
+        </a:solidFill>
+        <a:solidFill>
+          <a:schemeClr val="phClr"/>
+        </a:solidFill>
+      </a:fillStyleLst>
+      <a:lnStyleLst>
+        <a:ln w="9525">
+          <a:solidFill>
+            <a:schemeClr val="phClr"/>
+          </a:solidFill>
+        </a:ln>
+        <a:ln w="25400">
+          <a:solidFill>
+            <a:schemeClr val="phClr"/>
+          </a:solidFill>
+        </a:ln>
+        <a:ln w="38100">
+          <a:solidFill>
+            <a:schemeClr val="phClr"/>
+          </a:solidFill>
+        </a:ln>
+      </a:lnStyleLst>
+      <a:effectStyleLst>
+        <a:effectStyle>
+          <a:effectLst/>
+        </a:effectStyle>
+        <a:effectStyle>
+          <a:effectLst/>
+        </a:effectStyle>
+        <a:effectStyle>
+          <a:effectLst/>
+        </a:effectStyle>
+      </a:effectStyleLst>
+      <a:bgFillStyleLst>
+        <a:solidFill>
+          <a:schemeClr val="phClr"/>
+        </a:solidFill>
+        <a:solidFill>
+          <a:schemeClr val="phClr"/>
+        </a:solidFill>
+        <a:solidFill>
+          <a:schemeClr val="phClr"/>
+        </a:solidFill>
+      </a:bgFillStyleLst>
+    </a:fmtScheme>
+  </a:themeElements>
+</a:theme>
 </file>
</xml_diff>